<commit_message>
Use the purchase orders project as the running example in the decks
Regenerates the 45 lesson decks with the new module numbering and
replaces the /DMO/ travel scenario and the S4D430 employee scenario
with code from sap-abap-rap-pedidos-de-compras-app: item, order and
customer business objects, EML, validations, feature control, the
T100 exception class, authorization checks, the ViaCEP client (BTP and
On-Premise), unit tests, CDS views and the Fiori elements app.

Where the project has no counterpart (BO interface, inheritance, foreign
key, enum, FPM extensions), the slide uses the project domain and says
the example is illustrative. Icons from the reference library replace
the matching Tabler icons, painted in the color of each context.

Co-Authored-By: Claude Opus 5.5 <noreply@anthropic.com>
</commit_message>
<xml_diff>
--- a/modulo-01/01.00_ABAP_moderno_uma_jornada_essencial.pptx
+++ b/modulo-01/01.00_ABAP_moderno_uma_jornada_essencial.pptx
@@ -3766,7 +3766,7 @@
         </p:blipFill>
         <p:spPr>
           <a:xfrm>
-            <a:off x="6511900" y="2694432"/>
+            <a:off x="9342653" y="2694432"/>
             <a:ext cx="256032" cy="256032"/>
           </a:xfrm>
           <a:prstGeom prst="rect">
@@ -3790,7 +3790,7 @@
         </p:blipFill>
         <p:spPr>
           <a:xfrm>
-            <a:off x="9342653" y="2694432"/>
+            <a:off x="6511900" y="2694432"/>
             <a:ext cx="256032" cy="256032"/>
           </a:xfrm>
           <a:prstGeom prst="rect">
@@ -4618,7 +4618,7 @@
         </p:blipFill>
         <p:spPr>
           <a:xfrm>
-            <a:off x="822960" y="3886200"/>
+            <a:off x="6355080" y="3886200"/>
             <a:ext cx="256032" cy="256032"/>
           </a:xfrm>
           <a:prstGeom prst="rect">
@@ -4642,7 +4642,7 @@
         </p:blipFill>
         <p:spPr>
           <a:xfrm>
-            <a:off x="6355080" y="3886200"/>
+            <a:off x="822960" y="3886200"/>
             <a:ext cx="256032" cy="256032"/>
           </a:xfrm>
           <a:prstGeom prst="rect">
@@ -6185,8 +6185,8 @@
         </p:blipFill>
         <p:spPr>
           <a:xfrm>
-            <a:off x="5455768" y="1847088"/>
-            <a:ext cx="347472" cy="347472"/>
+            <a:off x="749808" y="5751576"/>
+            <a:ext cx="310896" cy="310896"/>
           </a:xfrm>
           <a:prstGeom prst="rect">
             <a:avLst/>
@@ -6209,7 +6209,7 @@
         </p:blipFill>
         <p:spPr>
           <a:xfrm>
-            <a:off x="2636444" y="1847088"/>
+            <a:off x="5455768" y="1847088"/>
             <a:ext cx="347472" cy="347472"/>
           </a:xfrm>
           <a:prstGeom prst="rect">
@@ -6233,7 +6233,7 @@
         </p:blipFill>
         <p:spPr>
           <a:xfrm>
-            <a:off x="8275091" y="1847088"/>
+            <a:off x="2636444" y="3858768"/>
             <a:ext cx="347472" cy="347472"/>
           </a:xfrm>
           <a:prstGeom prst="rect">
@@ -6257,7 +6257,7 @@
         </p:blipFill>
         <p:spPr>
           <a:xfrm>
-            <a:off x="11094415" y="1847088"/>
+            <a:off x="8275091" y="1847088"/>
             <a:ext cx="347472" cy="347472"/>
           </a:xfrm>
           <a:prstGeom prst="rect">
@@ -6281,7 +6281,7 @@
         </p:blipFill>
         <p:spPr>
           <a:xfrm>
-            <a:off x="2636444" y="3858768"/>
+            <a:off x="2636444" y="1847088"/>
             <a:ext cx="347472" cy="347472"/>
           </a:xfrm>
           <a:prstGeom prst="rect">
@@ -6305,7 +6305,7 @@
         </p:blipFill>
         <p:spPr>
           <a:xfrm>
-            <a:off x="5455768" y="3858768"/>
+            <a:off x="8275091" y="3858768"/>
             <a:ext cx="347472" cy="347472"/>
           </a:xfrm>
           <a:prstGeom prst="rect">
@@ -6329,7 +6329,7 @@
         </p:blipFill>
         <p:spPr>
           <a:xfrm>
-            <a:off x="8275091" y="3858768"/>
+            <a:off x="11094415" y="1847088"/>
             <a:ext cx="347472" cy="347472"/>
           </a:xfrm>
           <a:prstGeom prst="rect">
@@ -6353,7 +6353,7 @@
         </p:blipFill>
         <p:spPr>
           <a:xfrm>
-            <a:off x="11094415" y="3858768"/>
+            <a:off x="5455768" y="3858768"/>
             <a:ext cx="347472" cy="347472"/>
           </a:xfrm>
           <a:prstGeom prst="rect">
@@ -6377,8 +6377,8 @@
         </p:blipFill>
         <p:spPr>
           <a:xfrm>
-            <a:off x="749808" y="5751576"/>
-            <a:ext cx="310896" cy="310896"/>
+            <a:off x="11094415" y="3858768"/>
+            <a:ext cx="347472" cy="347472"/>
           </a:xfrm>
           <a:prstGeom prst="rect">
             <a:avLst/>
@@ -11877,7 +11877,7 @@
         <p:spPr>
           <a:xfrm>
             <a:off x="640080" y="1700784"/>
-            <a:ext cx="1764792" cy="292608"/>
+            <a:ext cx="2852928" cy="292608"/>
           </a:xfrm>
           <a:prstGeom prst="rect">
             <a:avLst/>
@@ -11897,7 +11897,7 @@
         <p:spPr>
           <a:xfrm>
             <a:off x="640080" y="1700784"/>
-            <a:ext cx="1764792" cy="27432"/>
+            <a:ext cx="2852928" cy="27432"/>
           </a:xfrm>
           <a:prstGeom prst="rect">
             <a:avLst/>
@@ -11917,7 +11917,7 @@
         <p:spPr>
           <a:xfrm>
             <a:off x="731520" y="1719072"/>
-            <a:ext cx="1581912" cy="274320"/>
+            <a:ext cx="2670048" cy="274320"/>
           </a:xfrm>
           <a:prstGeom prst="rect">
             <a:avLst/>
@@ -11938,7 +11938,7 @@
                   <a:srgbClr val="FFFFFF"/>
                 </a:solidFill>
               </a:rPr>
-              <a:t>zcl_voos.clas.abap</a:t>
+              <a:t>zcl_pc_pedidos_abertos.clas.abap</a:t>
             </a:r>
             <a:endParaRPr lang="en-US" sz="950" dirty="0"/>
           </a:p>
@@ -11974,7 +11974,7 @@
                   <a:srgbClr val="9DA5B4"/>
                 </a:solidFill>
               </a:rPr>
-              <a:t>ZS4D400_## › ZCL_VOOS</a:t>
+              <a:t>Projeto Pedidos de Compras › consulta sobre ZR_PC_PEDIDO</a:t>
             </a:r>
             <a:endParaRPr lang="en-US" sz="850" dirty="0"/>
           </a:p>
@@ -12420,7 +12420,7 @@
                 <a:ea typeface="Courier New" pitchFamily="34" charset="-122"/>
                 <a:cs typeface="Courier New" pitchFamily="34" charset="-120"/>
               </a:rPr>
-              <a:t>zcl_voos</a:t>
+              <a:t>zcl_pc_pedidos_abertos</a:t>
             </a:r>
             <a:r>
               <a:rPr lang="en-US" sz="1050" dirty="0">
@@ -12762,7 +12762,7 @@
                 <a:ea typeface="Courier New" pitchFamily="34" charset="-122"/>
                 <a:cs typeface="Courier New" pitchFamily="34" charset="-120"/>
               </a:rPr>
-              <a:t>zcl_voos</a:t>
+              <a:t>zcl_pc_pedidos_abertos</a:t>
             </a:r>
             <a:r>
               <a:rPr lang="en-US" sz="1050" dirty="0">
@@ -12928,13 +12928,13 @@
             <a:r>
               <a:rPr lang="en-US" sz="1050" dirty="0">
                 <a:solidFill>
-                  <a:srgbClr val="4EC9B0"/>
-                </a:solidFill>
-                <a:latin typeface="Courier New" pitchFamily="34" charset="0"/>
-                <a:ea typeface="Courier New" pitchFamily="34" charset="-122"/>
-                <a:cs typeface="Courier New" pitchFamily="34" charset="-120"/>
-              </a:rPr>
-              <a:t>/DMO/I_Connection</a:t>
+                  <a:srgbClr val="CCCCCC"/>
+                </a:solidFill>
+                <a:latin typeface="Courier New" pitchFamily="34" charset="0"/>
+                <a:ea typeface="Courier New" pitchFamily="34" charset="-122"/>
+                <a:cs typeface="Courier New" pitchFamily="34" charset="-120"/>
+              </a:rPr>
+              <a:t>zr_pc_pedido</a:t>
             </a:r>
             <a:endParaRPr lang="en-US" sz="1050" dirty="0"/>
           </a:p>
@@ -12987,7 +12987,7 @@
                 <a:ea typeface="Courier New" pitchFamily="34" charset="-122"/>
                 <a:cs typeface="Courier New" pitchFamily="34" charset="-120"/>
               </a:rPr>
-              <a:t>AirlineID</a:t>
+              <a:t>NumeroPedido</a:t>
             </a:r>
             <a:r>
               <a:rPr lang="en-US" sz="1050" dirty="0">
@@ -13020,7 +13020,40 @@
                 <a:ea typeface="Courier New" pitchFamily="34" charset="-122"/>
                 <a:cs typeface="Courier New" pitchFamily="34" charset="-120"/>
               </a:rPr>
-              <a:t>ConnectionID</a:t>
+              <a:t>ValorTotal</a:t>
+            </a:r>
+            <a:r>
+              <a:rPr lang="en-US" sz="1050" dirty="0">
+                <a:solidFill>
+                  <a:srgbClr val="CCCCCC"/>
+                </a:solidFill>
+                <a:latin typeface="Courier New" pitchFamily="34" charset="0"/>
+                <a:ea typeface="Courier New" pitchFamily="34" charset="-122"/>
+                <a:cs typeface="Courier New" pitchFamily="34" charset="-120"/>
+              </a:rPr>
+              <a:t>,</a:t>
+            </a:r>
+            <a:r>
+              <a:rPr lang="en-US" sz="1050" dirty="0">
+                <a:solidFill>
+                  <a:srgbClr val="CCCCCC"/>
+                </a:solidFill>
+                <a:latin typeface="Courier New" pitchFamily="34" charset="0"/>
+                <a:ea typeface="Courier New" pitchFamily="34" charset="-122"/>
+                <a:cs typeface="Courier New" pitchFamily="34" charset="-120"/>
+              </a:rPr>
+              <a:t> </a:t>
+            </a:r>
+            <a:r>
+              <a:rPr lang="en-US" sz="1050" dirty="0">
+                <a:solidFill>
+                  <a:srgbClr val="CCCCCC"/>
+                </a:solidFill>
+                <a:latin typeface="Courier New" pitchFamily="34" charset="0"/>
+                <a:ea typeface="Courier New" pitchFamily="34" charset="-122"/>
+                <a:cs typeface="Courier New" pitchFamily="34" charset="-120"/>
+              </a:rPr>
+              <a:t>Currency</a:t>
             </a:r>
             <a:r>
               <a:rPr lang="en-US" sz="1050" dirty="0">
@@ -13073,7 +13106,7 @@
                 <a:ea typeface="Courier New" pitchFamily="34" charset="-122"/>
                 <a:cs typeface="Courier New" pitchFamily="34" charset="-120"/>
               </a:rPr>
-              <a:t>_Airline-Name</a:t>
+              <a:t>_Cliente-Nome</a:t>
             </a:r>
             <a:r>
               <a:rPr lang="en-US" sz="1050" dirty="0">
@@ -13117,7 +13150,7 @@
                 <a:ea typeface="Courier New" pitchFamily="34" charset="-122"/>
                 <a:cs typeface="Courier New" pitchFamily="34" charset="-120"/>
               </a:rPr>
-              <a:t>Airline</a:t>
+              <a:t>Cliente</a:t>
             </a:r>
             <a:endParaRPr lang="en-US" sz="1050" dirty="0"/>
           </a:p>
@@ -13170,7 +13203,7 @@
                 <a:ea typeface="Courier New" pitchFamily="34" charset="-122"/>
                 <a:cs typeface="Courier New" pitchFamily="34" charset="-120"/>
               </a:rPr>
-              <a:t>DepartureAirport</a:t>
+              <a:t>StatusPedido</a:t>
             </a:r>
             <a:r>
               <a:rPr lang="en-US" sz="1050" dirty="0">
@@ -13214,7 +13247,7 @@
                 <a:ea typeface="Courier New" pitchFamily="34" charset="-122"/>
                 <a:cs typeface="Courier New" pitchFamily="34" charset="-120"/>
               </a:rPr>
-              <a:t>'FRA'</a:t>
+              <a:t>'ABERTO'</a:t>
             </a:r>
             <a:endParaRPr lang="en-US" sz="1050" dirty="0"/>
           </a:p>
@@ -13322,7 +13355,7 @@
                 <a:ea typeface="Courier New" pitchFamily="34" charset="-122"/>
                 <a:cs typeface="Courier New" pitchFamily="34" charset="-120"/>
               </a:rPr>
-              <a:t>flights</a:t>
+              <a:t>pedidos</a:t>
             </a:r>
             <a:r>
               <a:rPr lang="en-US" sz="1050" dirty="0">
@@ -13439,7 +13472,7 @@
                 <a:ea typeface="Courier New" pitchFamily="34" charset="-122"/>
                 <a:cs typeface="Courier New" pitchFamily="34" charset="-120"/>
               </a:rPr>
-              <a:t>flights</a:t>
+              <a:t>pedidos</a:t>
             </a:r>
             <a:r>
               <a:rPr lang="en-US" sz="1050" dirty="0">
@@ -13505,7 +13538,7 @@
                 <a:ea typeface="Courier New" pitchFamily="34" charset="-122"/>
                 <a:cs typeface="Courier New" pitchFamily="34" charset="-120"/>
               </a:rPr>
-              <a:t>flight</a:t>
+              <a:t>pedido</a:t>
             </a:r>
             <a:r>
               <a:rPr lang="en-US" sz="1050" dirty="0">
@@ -13613,7 +13646,7 @@
                 <a:ea typeface="Courier New" pitchFamily="34" charset="-122"/>
                 <a:cs typeface="Courier New" pitchFamily="34" charset="-120"/>
               </a:rPr>
-              <a:t>|{ flight-Airline }: { flight-ConnectionID }|</a:t>
+              <a:t>|{ pedido-NumeroPedido }: { pedido-Cliente }|</a:t>
             </a:r>
             <a:r>
               <a:rPr lang="en-US" sz="1050" dirty="0">
@@ -14024,7 +14057,7 @@
                   <a:srgbClr val="556B82"/>
                 </a:solidFill>
               </a:rPr>
-              <a:t>Lê da view liberada e da associação </a:t>
+              <a:t>Lê a view do BO Pedido e, pela associação </a:t>
             </a:r>
             <a:r>
               <a:rPr lang="en-US" sz="1050" dirty="0">
@@ -14035,7 +14068,7 @@
                 <a:ea typeface="Courier New" pitchFamily="34" charset="-122"/>
                 <a:cs typeface="Courier New" pitchFamily="34" charset="-120"/>
               </a:rPr>
-              <a:t>_Airline</a:t>
+              <a:t>_Cliente</a:t>
             </a:r>
             <a:r>
               <a:rPr lang="en-US" sz="1050" dirty="0">
@@ -14043,7 +14076,7 @@
                   <a:srgbClr val="556B82"/>
                 </a:solidFill>
               </a:rPr>
-              <a:t>.</a:t>
+              <a:t>, o nome do cliente.</a:t>
             </a:r>
             <a:endParaRPr lang="en-US" sz="1400" dirty="0"/>
           </a:p>

</xml_diff>